<commit_message>
docs: capturar os documentos agora que o modulo funciona
Com o upload reparado, os dois ecras que mostravam "Nenhum documento"
passam a ter conteudo real: o separador Documentos do processo e o
repositorio central. Ambos recapturados com tres pecas do cenario do
manual -- procuracao (restrita), peca processual e comprovativo de taxa
de justica -- uma delas em v2, para o versionamento ficar visivel.

O slide dos separadores dizia que "a lista surge vazia enquanto nada
tiver sido carregado", redacao escolhida quando o upload nao funcionava
para nao prometer o que a imagem nao mostrava. Deixou de ser verdade:
passa a descrever o que la esta.

Apresentacao e manual HTML regenerados a partir das imagens novas.

Co-Authored-By: Claude Opus 5 <noreply@anthropic.com>
Claude-Session: https://claude.ai/code/session_018isZooh7iBZEm3XRWCKUbu
</commit_message>
<xml_diff>
--- a/docs/MANUAL_DO_UTILIZADOR.pptx
+++ b/docs/MANUAL_DO_UTILIZADOR.pptx
@@ -17515,7 +17515,7 @@
                 <a:ea typeface="Calibri" pitchFamily="34" charset="-122"/>
                 <a:cs typeface="Calibri" pitchFamily="34" charset="-120"/>
               </a:rPr>
-              <a:t>Documentos — peças vinculadas ao processo.</a:t>
+              <a:t>Documentos — peças do processo, com versionamento (v1/v2).</a:t>
             </a:r>
             <a:endParaRPr lang="en-US" sz="1000" dirty="0"/>
           </a:p>
@@ -17596,7 +17596,7 @@
                 <a:ea typeface="Calibri" pitchFamily="34" charset="-122"/>
                 <a:cs typeface="Calibri" pitchFamily="34" charset="-120"/>
               </a:rPr>
-              <a:t>Arquivo das peças vinculadas: procurações, certidões e comprovativos. A lista surge vazia enquanto nada tiver sido carregado.</a:t>
+              <a:t>Peças, procurações e comprovativos, com tipo, confidencialidade, versão e tamanho.</a:t>
             </a:r>
             <a:endParaRPr lang="en-US" sz="1100" dirty="0"/>
           </a:p>

</xml_diff>

<commit_message>
feat(129): rebrand ALCv → LexCV in active docs and commercial docs
CLAUDE.md, DEPLOYMENT.md, backend/migrations/README.md, .trae/documents/SPEC.md,
docs/MANUAL_DO_UTILIZADOR.{md,html,pptx} (+ generator scripts), and business/
documentation now refer to LexCV. Reserved production domain alcv.tech left
unchanged (explicit decision). Fixed stale admin@alcv.cv doc references to
match the real seeded admin@lexcv.cv.

Co-Authored-By: Claude Sonnet 5 <noreply@anthropic.com>
Claude-Session: https://claude.ai/code/session_01JJeJW3WQUa1GoEjVDcxtU7
</commit_message>
<xml_diff>
--- a/docs/MANUAL_DO_UTILIZADOR.pptx
+++ b/docs/MANUAL_DO_UTILIZADOR.pptx
@@ -542,7 +542,7 @@
           <a:p>
             <a:r>
               <a:rPr lang="en-US" dirty="0"/>
-              <a:t>Capa. Manual do Utilizador da Plataforma Jurídica ALCv, versão 1.0, Setembro de 2026.</a:t>
+              <a:t>Capa. Manual do Utilizador da Plataforma Jurídica LexCV, versão 1.0, Setembro de 2026.</a:t>
             </a:r>
             <a:endParaRPr lang="en-US" dirty="0"/>
           </a:p>
@@ -4518,7 +4518,7 @@
                 <a:ea typeface="Calibri" pitchFamily="34" charset="-122"/>
                 <a:cs typeface="Calibri" pitchFamily="34" charset="-120"/>
               </a:rPr>
-              <a:t>ALCv</a:t>
+              <a:t>LexCV</a:t>
             </a:r>
             <a:endParaRPr lang="en-US" sz="1500" dirty="0"/>
           </a:p>
@@ -27932,7 +27932,7 @@
                 <a:ea typeface="Calibri" pitchFamily="34" charset="-122"/>
                 <a:cs typeface="Calibri" pitchFamily="34" charset="-120"/>
               </a:rPr>
-              <a:t>O ALCv é uma plataforma integrada de gestão forense desenhada para a realidade de Cabo Verde, cobrindo a tramitação nos tribunais de comarca, tribunais de relação e Supremo Tribunal de Justiça.</a:t>
+              <a:t>O LexCV é uma plataforma integrada de gestão forense desenhada para a realidade de Cabo Verde, cobrindo a tramitação nos tribunais de comarca, tribunais de relação e Supremo Tribunal de Justiça.</a:t>
             </a:r>
             <a:endParaRPr lang="en-US" sz="1300" dirty="0"/>
           </a:p>
@@ -30685,7 +30685,7 @@
                 <a:ea typeface="Calibri" pitchFamily="34" charset="-122"/>
                 <a:cs typeface="Calibri" pitchFamily="34" charset="-120"/>
               </a:rPr>
-              <a:t>ALCv · www.alcv.tech</a:t>
+              <a:t>LexCV · www.alcv.tech</a:t>
             </a:r>
             <a:endParaRPr lang="en-US" sz="1200" dirty="0"/>
           </a:p>
@@ -30724,7 +30724,7 @@
                 <a:ea typeface="Calibri" pitchFamily="34" charset="-122"/>
                 <a:cs typeface="Calibri" pitchFamily="34" charset="-120"/>
               </a:rPr>
-              <a:t>© 2026 ALCv. Todos os direitos reservados.</a:t>
+              <a:t>© 2026 LexCV. Todos os direitos reservados.</a:t>
             </a:r>
             <a:endParaRPr lang="en-US" sz="1050" dirty="0"/>
           </a:p>
@@ -31371,7 +31371,7 @@
                 <a:ea typeface="Calibri" pitchFamily="34" charset="-122"/>
                 <a:cs typeface="Calibri" pitchFamily="34" charset="-120"/>
               </a:rPr>
-              <a:t>Utilizador: admin@alcv.cv</a:t>
+              <a:t>Utilizador: admin@lexcv.cv</a:t>
             </a:r>
             <a:endParaRPr lang="en-US" sz="1150" dirty="0"/>
           </a:p>

</xml_diff>